<commit_message>
fix: optimize performance, JS render loop, and disable heavy CSS blurs to prevent dGPU wakeup
</commit_message>
<xml_diff>
--- a/.dev_workspace/Project_Wireframes_Proper.pptx
+++ b/.dev_workspace/Project_Wireframes_Proper.pptx
@@ -2011,6 +2011,14 @@
 <file path=ppt/slides/slide1.xml><?xml version="1.0" encoding="utf-8"?>
 <p:sld xmlns:a="http://schemas.openxmlformats.org/drawingml/2006/main" xmlns:r="http://schemas.openxmlformats.org/officeDocument/2006/relationships" xmlns:p="http://schemas.openxmlformats.org/presentationml/2006/main">
   <p:cSld name="Slide 1">
+    <p:bg>
+      <p:bgPr>
+        <a:solidFill>
+          <a:srgbClr val="1E1E2E"/>
+        </a:solidFill>
+        <a:effectLst/>
+      </p:bgPr>
+    </p:bg>
     <p:spTree>
       <p:nvGrpSpPr>
         <p:cNvPr id="1" name=""/>
@@ -2052,7 +2060,7 @@
             <a:r>
               <a:rPr lang="en-US" sz="1800" b="1" dirty="0">
                 <a:solidFill>
-                  <a:srgbClr val="363636"/>
+                  <a:srgbClr val="CDD6F4"/>
                 </a:solidFill>
               </a:rPr>
               <a:t>Nexus Tracker</a:t>
@@ -2111,6 +2119,10 @@
             <a:prstDash val="solid"/>
           </a:ln>
         </p:spPr>
+        <p:txBody>
+          <a:bodyPr/>
+          <a:p/>
+        </p:txBody>
       </p:sp>
       <p:sp>
         <p:nvSpPr>
@@ -2139,7 +2151,7 @@
             <a:r>
               <a:rPr lang="en-US" sz="2400" b="1" dirty="0">
                 <a:solidFill>
-                  <a:srgbClr val="003366"/>
+                  <a:srgbClr val="CDD6F4"/>
                 </a:solidFill>
               </a:rPr>
               <a:t>Client Page 1: Welcome (index)</a:t>
@@ -2163,10 +2175,14 @@
             <a:avLst/>
           </a:prstGeom>
           <a:solidFill>
-            <a:srgbClr val="222222"/>
+            <a:srgbClr val="181825"/>
           </a:solidFill>
           <a:ln/>
         </p:spPr>
+        <p:txBody>
+          <a:bodyPr/>
+          <a:p/>
+        </p:txBody>
       </p:sp>
       <p:sp>
         <p:nvSpPr>
@@ -2195,7 +2211,7 @@
             <a:r>
               <a:rPr lang="en-US" sz="2800" b="1" dirty="0">
                 <a:solidFill>
-                  <a:srgbClr val="00FFFF"/>
+                  <a:srgbClr val="CDD6F4"/>
                 </a:solidFill>
               </a:rPr>
               <a:t>N E X U S</a:t>
@@ -2219,10 +2235,14 @@
             <a:avLst/>
           </a:prstGeom>
           <a:solidFill>
-            <a:srgbClr val="0066CC"/>
+            <a:srgbClr val="181825"/>
           </a:solidFill>
           <a:ln/>
         </p:spPr>
+        <p:txBody>
+          <a:bodyPr/>
+          <a:p/>
+        </p:txBody>
       </p:sp>
       <p:sp>
         <p:nvSpPr>
@@ -2251,7 +2271,7 @@
             <a:r>
               <a:rPr lang="en-US" b="1" dirty="0">
                 <a:solidFill>
-                  <a:srgbClr val="FFFFFF"/>
+                  <a:srgbClr val="CDD6F4"/>
                 </a:solidFill>
               </a:rPr>
               <a:t>GET STARTED</a:t>
@@ -2282,6 +2302,10 @@
             <a:prstDash val="solid"/>
           </a:ln>
         </p:spPr>
+        <p:txBody>
+          <a:bodyPr/>
+          <a:p/>
+        </p:txBody>
       </p:sp>
       <p:sp>
         <p:nvSpPr>
@@ -2310,7 +2334,7 @@
             <a:r>
               <a:rPr lang="en-US" sz="1000" dirty="0">
                 <a:solidFill>
-                  <a:srgbClr val="999999"/>
+                  <a:srgbClr val="CDD6F4"/>
                 </a:solidFill>
               </a:rPr>
               <a:t>Footer - Copyright © 2026 Nexus</a:t>
@@ -2330,6 +2354,14 @@
 <file path=ppt/slides/slide10.xml><?xml version="1.0" encoding="utf-8"?>
 <p:sld xmlns:a="http://schemas.openxmlformats.org/drawingml/2006/main" xmlns:r="http://schemas.openxmlformats.org/officeDocument/2006/relationships" xmlns:p="http://schemas.openxmlformats.org/presentationml/2006/main">
   <p:cSld name="Slide 10">
+    <p:bg>
+      <p:bgPr>
+        <a:solidFill>
+          <a:srgbClr val="1E1E2E"/>
+        </a:solidFill>
+        <a:effectLst/>
+      </p:bgPr>
+    </p:bg>
     <p:spTree>
       <p:nvGrpSpPr>
         <p:cNvPr id="1" name=""/>
@@ -2359,10 +2391,14 @@
             <a:avLst/>
           </a:prstGeom>
           <a:solidFill>
-            <a:srgbClr val="222222"/>
+            <a:srgbClr val="181825"/>
           </a:solidFill>
           <a:ln/>
         </p:spPr>
+        <p:txBody>
+          <a:bodyPr/>
+          <a:p/>
+        </p:txBody>
       </p:sp>
       <p:sp>
         <p:nvSpPr>
@@ -2391,7 +2427,7 @@
             <a:r>
               <a:rPr lang="en-US" sz="1600" b="1" dirty="0">
                 <a:solidFill>
-                  <a:srgbClr val="FFFFFF"/>
+                  <a:srgbClr val="CDD6F4"/>
                 </a:solidFill>
               </a:rPr>
               <a:t>Nexus ADMIN</a:t>
@@ -2427,7 +2463,7 @@
             <a:r>
               <a:rPr lang="en-US" sz="1100" dirty="0">
                 <a:solidFill>
-                  <a:srgbClr val="CCCCCC"/>
+                  <a:srgbClr val="CDD6F4"/>
                 </a:solidFill>
               </a:rPr>
               <a:t>[Dashboard] [Games] [Users] [Analytics] [Inbox] [Logs] [Settings]</a:t>
@@ -2463,7 +2499,7 @@
             <a:r>
               <a:rPr lang="en-US" sz="2000" b="1" dirty="0">
                 <a:solidFill>
-                  <a:srgbClr val="000000"/>
+                  <a:srgbClr val="CDD6F4"/>
                 </a:solidFill>
               </a:rPr>
               <a:t>Admin Page 3: Users Management</a:t>
@@ -2487,7 +2523,7 @@
             <a:avLst/>
           </a:prstGeom>
           <a:solidFill>
-            <a:srgbClr val="FFFFFF"/>
+            <a:srgbClr val="181825"/>
           </a:solidFill>
           <a:ln w="12700">
             <a:solidFill>
@@ -2496,6 +2532,10 @@
             <a:prstDash val="solid"/>
           </a:ln>
         </p:spPr>
+        <p:txBody>
+          <a:bodyPr/>
+          <a:p/>
+        </p:txBody>
       </p:sp>
       <p:sp>
         <p:nvSpPr>
@@ -2524,7 +2564,7 @@
             <a:r>
               <a:rPr lang="en-US" sz="1200" b="1" dirty="0">
                 <a:solidFill>
-                  <a:srgbClr val="000000"/>
+                  <a:srgbClr val="CDD6F4"/>
                 </a:solidFill>
               </a:rPr>
               <a:t>UID    Username                  Role        Last Login    Actions</a:t>
@@ -2555,6 +2595,10 @@
             <a:prstDash val="solid"/>
           </a:ln>
         </p:spPr>
+        <p:txBody>
+          <a:bodyPr/>
+          <a:p/>
+        </p:txBody>
       </p:sp>
       <p:sp>
         <p:nvSpPr>
@@ -2583,7 +2627,7 @@
             <a:r>
               <a:rPr lang="en-US" sz="1200" dirty="0">
                 <a:solidFill>
-                  <a:srgbClr val="000000"/>
+                  <a:srgbClr val="CDD6F4"/>
                 </a:solidFill>
               </a:rPr>
               <a:t>101    PlayerOne                 Member      Today         [Edit] [Ban]</a:t>
@@ -2614,6 +2658,10 @@
             <a:prstDash val="solid"/>
           </a:ln>
         </p:spPr>
+        <p:txBody>
+          <a:bodyPr/>
+          <a:p/>
+        </p:txBody>
       </p:sp>
       <p:sp>
         <p:nvSpPr>
@@ -2642,7 +2690,7 @@
             <a:r>
               <a:rPr lang="en-US" sz="1000" dirty="0">
                 <a:solidFill>
-                  <a:srgbClr val="999999"/>
+                  <a:srgbClr val="CDD6F4"/>
                 </a:solidFill>
               </a:rPr>
               <a:t>Footer - Copyright © 2026 Nexus</a:t>
@@ -2662,6 +2710,14 @@
 <file path=ppt/slides/slide11.xml><?xml version="1.0" encoding="utf-8"?>
 <p:sld xmlns:a="http://schemas.openxmlformats.org/drawingml/2006/main" xmlns:r="http://schemas.openxmlformats.org/officeDocument/2006/relationships" xmlns:p="http://schemas.openxmlformats.org/presentationml/2006/main">
   <p:cSld name="Slide 11">
+    <p:bg>
+      <p:bgPr>
+        <a:solidFill>
+          <a:srgbClr val="1E1E2E"/>
+        </a:solidFill>
+        <a:effectLst/>
+      </p:bgPr>
+    </p:bg>
     <p:spTree>
       <p:nvGrpSpPr>
         <p:cNvPr id="1" name=""/>
@@ -2691,10 +2747,14 @@
             <a:avLst/>
           </a:prstGeom>
           <a:solidFill>
-            <a:srgbClr val="222222"/>
+            <a:srgbClr val="181825"/>
           </a:solidFill>
           <a:ln/>
         </p:spPr>
+        <p:txBody>
+          <a:bodyPr/>
+          <a:p/>
+        </p:txBody>
       </p:sp>
       <p:sp>
         <p:nvSpPr>
@@ -2723,7 +2783,7 @@
             <a:r>
               <a:rPr lang="en-US" sz="1600" b="1" dirty="0">
                 <a:solidFill>
-                  <a:srgbClr val="FFFFFF"/>
+                  <a:srgbClr val="CDD6F4"/>
                 </a:solidFill>
               </a:rPr>
               <a:t>Nexus ADMIN</a:t>
@@ -2759,7 +2819,7 @@
             <a:r>
               <a:rPr lang="en-US" sz="1100" dirty="0">
                 <a:solidFill>
-                  <a:srgbClr val="CCCCCC"/>
+                  <a:srgbClr val="CDD6F4"/>
                 </a:solidFill>
               </a:rPr>
               <a:t>[Dashboard] [Games] [Users] [Analytics] [Inbox] [Logs] [Settings]</a:t>
@@ -2795,7 +2855,7 @@
             <a:r>
               <a:rPr lang="en-US" sz="2000" b="1" dirty="0">
                 <a:solidFill>
-                  <a:srgbClr val="000000"/>
+                  <a:srgbClr val="CDD6F4"/>
                 </a:solidFill>
               </a:rPr>
               <a:t>Admin Page 4: Analytics</a:t>
@@ -2819,7 +2879,7 @@
             <a:avLst/>
           </a:prstGeom>
           <a:solidFill>
-            <a:srgbClr val="F9F9F9"/>
+            <a:srgbClr val="181825"/>
           </a:solidFill>
           <a:ln w="12700">
             <a:solidFill>
@@ -2828,6 +2888,10 @@
             <a:prstDash val="solid"/>
           </a:ln>
         </p:spPr>
+        <p:txBody>
+          <a:bodyPr/>
+          <a:p/>
+        </p:txBody>
       </p:sp>
       <p:sp>
         <p:nvSpPr>
@@ -2856,7 +2920,7 @@
             <a:r>
               <a:rPr lang="en-US" sz="1600" dirty="0">
                 <a:solidFill>
-                  <a:srgbClr val="999999"/>
+                  <a:srgbClr val="CDD6F4"/>
                 </a:solidFill>
               </a:rPr>
               <a:t>Traffic Chart (Last 7 Days) Placeholder</a:t>
@@ -2887,6 +2951,10 @@
             <a:prstDash val="solid"/>
           </a:ln>
         </p:spPr>
+        <p:txBody>
+          <a:bodyPr/>
+          <a:p/>
+        </p:txBody>
       </p:sp>
       <p:sp>
         <p:nvSpPr>
@@ -2915,7 +2983,7 @@
             <a:r>
               <a:rPr lang="en-US" sz="1000" dirty="0">
                 <a:solidFill>
-                  <a:srgbClr val="999999"/>
+                  <a:srgbClr val="CDD6F4"/>
                 </a:solidFill>
               </a:rPr>
               <a:t>Footer - Copyright © 2026 Nexus</a:t>
@@ -2935,6 +3003,14 @@
 <file path=ppt/slides/slide12.xml><?xml version="1.0" encoding="utf-8"?>
 <p:sld xmlns:a="http://schemas.openxmlformats.org/drawingml/2006/main" xmlns:r="http://schemas.openxmlformats.org/officeDocument/2006/relationships" xmlns:p="http://schemas.openxmlformats.org/presentationml/2006/main">
   <p:cSld name="Slide 12">
+    <p:bg>
+      <p:bgPr>
+        <a:solidFill>
+          <a:srgbClr val="1E1E2E"/>
+        </a:solidFill>
+        <a:effectLst/>
+      </p:bgPr>
+    </p:bg>
     <p:spTree>
       <p:nvGrpSpPr>
         <p:cNvPr id="1" name=""/>
@@ -2964,10 +3040,14 @@
             <a:avLst/>
           </a:prstGeom>
           <a:solidFill>
-            <a:srgbClr val="222222"/>
+            <a:srgbClr val="181825"/>
           </a:solidFill>
           <a:ln/>
         </p:spPr>
+        <p:txBody>
+          <a:bodyPr/>
+          <a:p/>
+        </p:txBody>
       </p:sp>
       <p:sp>
         <p:nvSpPr>
@@ -2996,7 +3076,7 @@
             <a:r>
               <a:rPr lang="en-US" sz="1600" b="1" dirty="0">
                 <a:solidFill>
-                  <a:srgbClr val="FFFFFF"/>
+                  <a:srgbClr val="CDD6F4"/>
                 </a:solidFill>
               </a:rPr>
               <a:t>Nexus ADMIN</a:t>
@@ -3032,7 +3112,7 @@
             <a:r>
               <a:rPr lang="en-US" sz="1100" dirty="0">
                 <a:solidFill>
-                  <a:srgbClr val="CCCCCC"/>
+                  <a:srgbClr val="CDD6F4"/>
                 </a:solidFill>
               </a:rPr>
               <a:t>[Dashboard] [Games] [Users] [Analytics] [Inbox] [Logs] [Settings]</a:t>
@@ -3068,7 +3148,7 @@
             <a:r>
               <a:rPr lang="en-US" sz="2000" b="1" dirty="0">
                 <a:solidFill>
-                  <a:srgbClr val="000000"/>
+                  <a:srgbClr val="CDD6F4"/>
                 </a:solidFill>
               </a:rPr>
               <a:t>Admin Page 5: Support Inbox</a:t>
@@ -3092,7 +3172,7 @@
             <a:avLst/>
           </a:prstGeom>
           <a:solidFill>
-            <a:srgbClr val="FFFFFF"/>
+            <a:srgbClr val="181825"/>
           </a:solidFill>
           <a:ln w="12700">
             <a:solidFill>
@@ -3101,6 +3181,10 @@
             <a:prstDash val="solid"/>
           </a:ln>
         </p:spPr>
+        <p:txBody>
+          <a:bodyPr/>
+          <a:p/>
+        </p:txBody>
       </p:sp>
       <p:sp>
         <p:nvSpPr>
@@ -3129,7 +3213,7 @@
             <a:r>
               <a:rPr lang="en-US" sz="1200" b="1" dirty="0">
                 <a:solidFill>
-                  <a:srgbClr val="000000"/>
+                  <a:srgbClr val="CDD6F4"/>
                 </a:solidFill>
               </a:rPr>
               <a:t>Operative              Channel               Transmission</a:t>
@@ -3160,6 +3244,10 @@
             <a:prstDash val="solid"/>
           </a:ln>
         </p:spPr>
+        <p:txBody>
+          <a:bodyPr/>
+          <a:p/>
+        </p:txBody>
       </p:sp>
       <p:sp>
         <p:nvSpPr>
@@ -3188,7 +3276,7 @@
             <a:r>
               <a:rPr lang="en-US" sz="1200" dirty="0">
                 <a:solidFill>
-                  <a:srgbClr val="000000"/>
+                  <a:srgbClr val="CDD6F4"/>
                 </a:solidFill>
               </a:rPr>
               <a:t>Jazzu                  jazz@email.com        I need help...</a:t>
@@ -3219,6 +3307,10 @@
             <a:prstDash val="solid"/>
           </a:ln>
         </p:spPr>
+        <p:txBody>
+          <a:bodyPr/>
+          <a:p/>
+        </p:txBody>
       </p:sp>
       <p:sp>
         <p:nvSpPr>
@@ -3247,7 +3339,7 @@
             <a:r>
               <a:rPr lang="en-US" sz="1000" dirty="0">
                 <a:solidFill>
-                  <a:srgbClr val="999999"/>
+                  <a:srgbClr val="CDD6F4"/>
                 </a:solidFill>
               </a:rPr>
               <a:t>Footer - Copyright © 2026 Nexus</a:t>
@@ -3267,6 +3359,14 @@
 <file path=ppt/slides/slide13.xml><?xml version="1.0" encoding="utf-8"?>
 <p:sld xmlns:a="http://schemas.openxmlformats.org/drawingml/2006/main" xmlns:r="http://schemas.openxmlformats.org/officeDocument/2006/relationships" xmlns:p="http://schemas.openxmlformats.org/presentationml/2006/main">
   <p:cSld name="Slide 13">
+    <p:bg>
+      <p:bgPr>
+        <a:solidFill>
+          <a:srgbClr val="1E1E2E"/>
+        </a:solidFill>
+        <a:effectLst/>
+      </p:bgPr>
+    </p:bg>
     <p:spTree>
       <p:nvGrpSpPr>
         <p:cNvPr id="1" name=""/>
@@ -3296,10 +3396,14 @@
             <a:avLst/>
           </a:prstGeom>
           <a:solidFill>
-            <a:srgbClr val="222222"/>
+            <a:srgbClr val="181825"/>
           </a:solidFill>
           <a:ln/>
         </p:spPr>
+        <p:txBody>
+          <a:bodyPr/>
+          <a:p/>
+        </p:txBody>
       </p:sp>
       <p:sp>
         <p:nvSpPr>
@@ -3328,7 +3432,7 @@
             <a:r>
               <a:rPr lang="en-US" sz="1600" b="1" dirty="0">
                 <a:solidFill>
-                  <a:srgbClr val="FFFFFF"/>
+                  <a:srgbClr val="CDD6F4"/>
                 </a:solidFill>
               </a:rPr>
               <a:t>Nexus ADMIN</a:t>
@@ -3364,7 +3468,7 @@
             <a:r>
               <a:rPr lang="en-US" sz="1100" dirty="0">
                 <a:solidFill>
-                  <a:srgbClr val="CCCCCC"/>
+                  <a:srgbClr val="CDD6F4"/>
                 </a:solidFill>
               </a:rPr>
               <a:t>[Dashboard] [Games] [Users] [Analytics] [Inbox] [Logs] [Settings]</a:t>
@@ -3400,7 +3504,7 @@
             <a:r>
               <a:rPr lang="en-US" sz="2000" b="1" dirty="0">
                 <a:solidFill>
-                  <a:srgbClr val="000000"/>
+                  <a:srgbClr val="CDD6F4"/>
                 </a:solidFill>
               </a:rPr>
               <a:t>Admin Page 6: Audit Logs</a:t>
@@ -3424,7 +3528,7 @@
             <a:avLst/>
           </a:prstGeom>
           <a:solidFill>
-            <a:srgbClr val="FFFFFF"/>
+            <a:srgbClr val="181825"/>
           </a:solidFill>
           <a:ln w="12700">
             <a:solidFill>
@@ -3433,6 +3537,10 @@
             <a:prstDash val="solid"/>
           </a:ln>
         </p:spPr>
+        <p:txBody>
+          <a:bodyPr/>
+          <a:p/>
+        </p:txBody>
       </p:sp>
       <p:sp>
         <p:nvSpPr>
@@ -3461,7 +3569,7 @@
             <a:r>
               <a:rPr lang="en-US" sz="1200" b="1" dirty="0">
                 <a:solidFill>
-                  <a:srgbClr val="000000"/>
+                  <a:srgbClr val="CDD6F4"/>
                 </a:solidFill>
               </a:rPr>
               <a:t>Timestamp            Event                              Severity</a:t>
@@ -3492,6 +3600,10 @@
             <a:prstDash val="solid"/>
           </a:ln>
         </p:spPr>
+        <p:txBody>
+          <a:bodyPr/>
+          <a:p/>
+        </p:txBody>
       </p:sp>
       <p:sp>
         <p:nvSpPr>
@@ -3520,7 +3632,7 @@
             <a:r>
               <a:rPr lang="en-US" sz="1200" dirty="0">
                 <a:solidFill>
-                  <a:srgbClr val="000000"/>
+                  <a:srgbClr val="CDD6F4"/>
                 </a:solidFill>
               </a:rPr>
               <a:t>2026-08-25 10:45     System Initialized                 INFO</a:t>
@@ -3551,6 +3663,10 @@
             <a:prstDash val="solid"/>
           </a:ln>
         </p:spPr>
+        <p:txBody>
+          <a:bodyPr/>
+          <a:p/>
+        </p:txBody>
       </p:sp>
       <p:sp>
         <p:nvSpPr>
@@ -3579,7 +3695,7 @@
             <a:r>
               <a:rPr lang="en-US" sz="1000" dirty="0">
                 <a:solidFill>
-                  <a:srgbClr val="999999"/>
+                  <a:srgbClr val="CDD6F4"/>
                 </a:solidFill>
               </a:rPr>
               <a:t>Footer - Copyright © 2026 Nexus</a:t>
@@ -3599,6 +3715,14 @@
 <file path=ppt/slides/slide14.xml><?xml version="1.0" encoding="utf-8"?>
 <p:sld xmlns:a="http://schemas.openxmlformats.org/drawingml/2006/main" xmlns:r="http://schemas.openxmlformats.org/officeDocument/2006/relationships" xmlns:p="http://schemas.openxmlformats.org/presentationml/2006/main">
   <p:cSld name="Slide 14">
+    <p:bg>
+      <p:bgPr>
+        <a:solidFill>
+          <a:srgbClr val="1E1E2E"/>
+        </a:solidFill>
+        <a:effectLst/>
+      </p:bgPr>
+    </p:bg>
     <p:spTree>
       <p:nvGrpSpPr>
         <p:cNvPr id="1" name=""/>
@@ -3628,10 +3752,14 @@
             <a:avLst/>
           </a:prstGeom>
           <a:solidFill>
-            <a:srgbClr val="222222"/>
+            <a:srgbClr val="181825"/>
           </a:solidFill>
           <a:ln/>
         </p:spPr>
+        <p:txBody>
+          <a:bodyPr/>
+          <a:p/>
+        </p:txBody>
       </p:sp>
       <p:sp>
         <p:nvSpPr>
@@ -3660,7 +3788,7 @@
             <a:r>
               <a:rPr lang="en-US" sz="1600" b="1" dirty="0">
                 <a:solidFill>
-                  <a:srgbClr val="FFFFFF"/>
+                  <a:srgbClr val="CDD6F4"/>
                 </a:solidFill>
               </a:rPr>
               <a:t>Nexus ADMIN</a:t>
@@ -3696,7 +3824,7 @@
             <a:r>
               <a:rPr lang="en-US" sz="1100" dirty="0">
                 <a:solidFill>
-                  <a:srgbClr val="CCCCCC"/>
+                  <a:srgbClr val="CDD6F4"/>
                 </a:solidFill>
               </a:rPr>
               <a:t>[Dashboard] [Games] [Users] [Analytics] [Inbox] [Logs] [Settings]</a:t>
@@ -3732,7 +3860,7 @@
             <a:r>
               <a:rPr lang="en-US" sz="2000" b="1" dirty="0">
                 <a:solidFill>
-                  <a:srgbClr val="000000"/>
+                  <a:srgbClr val="CDD6F4"/>
                 </a:solidFill>
               </a:rPr>
               <a:t>Admin Page 7: Settings</a:t>
@@ -3768,7 +3896,7 @@
             <a:r>
               <a:rPr lang="en-US" sz="1200" dirty="0">
                 <a:solidFill>
-                  <a:srgbClr val="000000"/>
+                  <a:srgbClr val="CDD6F4"/>
                 </a:solidFill>
               </a:rPr>
               <a:t>Site Name:     [ Nexus Tracker ]</a:t>
@@ -3804,7 +3932,7 @@
             <a:r>
               <a:rPr lang="en-US" sz="1200" dirty="0">
                 <a:solidFill>
-                  <a:srgbClr val="000000"/>
+                  <a:srgbClr val="CDD6F4"/>
                 </a:solidFill>
               </a:rPr>
               <a:t>Admin Email:   [ admin@nexus.local ]</a:t>
@@ -3828,10 +3956,14 @@
             <a:avLst/>
           </a:prstGeom>
           <a:solidFill>
-            <a:srgbClr val="0066CC"/>
+            <a:srgbClr val="181825"/>
           </a:solidFill>
           <a:ln/>
         </p:spPr>
+        <p:txBody>
+          <a:bodyPr/>
+          <a:p/>
+        </p:txBody>
       </p:sp>
       <p:sp>
         <p:nvSpPr>
@@ -3860,7 +3992,7 @@
             <a:r>
               <a:rPr lang="en-US" sz="1200" b="1" dirty="0">
                 <a:solidFill>
-                  <a:srgbClr val="FFFFFF"/>
+                  <a:srgbClr val="CDD6F4"/>
                 </a:solidFill>
               </a:rPr>
               <a:t>SAVE</a:t>
@@ -3891,6 +4023,10 @@
             <a:prstDash val="solid"/>
           </a:ln>
         </p:spPr>
+        <p:txBody>
+          <a:bodyPr/>
+          <a:p/>
+        </p:txBody>
       </p:sp>
       <p:sp>
         <p:nvSpPr>
@@ -3919,7 +4055,7 @@
             <a:r>
               <a:rPr lang="en-US" sz="1000" dirty="0">
                 <a:solidFill>
-                  <a:srgbClr val="999999"/>
+                  <a:srgbClr val="CDD6F4"/>
                 </a:solidFill>
               </a:rPr>
               <a:t>Footer - Copyright © 2026 Nexus</a:t>
@@ -3939,6 +4075,14 @@
 <file path=ppt/slides/slide2.xml><?xml version="1.0" encoding="utf-8"?>
 <p:sld xmlns:a="http://schemas.openxmlformats.org/drawingml/2006/main" xmlns:r="http://schemas.openxmlformats.org/officeDocument/2006/relationships" xmlns:p="http://schemas.openxmlformats.org/presentationml/2006/main">
   <p:cSld name="Slide 2">
+    <p:bg>
+      <p:bgPr>
+        <a:solidFill>
+          <a:srgbClr val="1E1E2E"/>
+        </a:solidFill>
+        <a:effectLst/>
+      </p:bgPr>
+    </p:bg>
     <p:spTree>
       <p:nvGrpSpPr>
         <p:cNvPr id="1" name=""/>
@@ -3980,7 +4124,7 @@
             <a:r>
               <a:rPr lang="en-US" sz="1800" b="1" dirty="0">
                 <a:solidFill>
-                  <a:srgbClr val="363636"/>
+                  <a:srgbClr val="CDD6F4"/>
                 </a:solidFill>
               </a:rPr>
               <a:t>Nexus Tracker</a:t>
@@ -4016,7 +4160,7 @@
             <a:r>
               <a:rPr lang="en-US" sz="1400" dirty="0">
                 <a:solidFill>
-                  <a:srgbClr val="666666"/>
+                  <a:srgbClr val="CDD6F4"/>
                 </a:solidFill>
               </a:rPr>
               <a:t>[Catalog]  [Search]  [Logbook]  [Contact]</a:t>
@@ -4047,6 +4191,10 @@
             <a:prstDash val="solid"/>
           </a:ln>
         </p:spPr>
+        <p:txBody>
+          <a:bodyPr/>
+          <a:p/>
+        </p:txBody>
       </p:sp>
       <p:sp>
         <p:nvSpPr>
@@ -4075,7 +4223,7 @@
             <a:r>
               <a:rPr lang="en-US" sz="2400" b="1" dirty="0">
                 <a:solidFill>
-                  <a:srgbClr val="003366"/>
+                  <a:srgbClr val="CDD6F4"/>
                 </a:solidFill>
               </a:rPr>
               <a:t>Client Page 2: Catalog</a:t>
@@ -4111,7 +4259,7 @@
             <a:r>
               <a:rPr lang="en-US" sz="1400" b="1" dirty="0">
                 <a:solidFill>
-                  <a:srgbClr val="000000"/>
+                  <a:srgbClr val="CDD6F4"/>
                 </a:solidFill>
               </a:rPr>
               <a:t>Featured Games</a:t>
@@ -4135,7 +4283,7 @@
             <a:avLst/>
           </a:prstGeom>
           <a:solidFill>
-            <a:srgbClr val="F5F5F5"/>
+            <a:srgbClr val="181825"/>
           </a:solidFill>
           <a:ln w="12700">
             <a:solidFill>
@@ -4144,6 +4292,10 @@
             <a:prstDash val="solid"/>
           </a:ln>
         </p:spPr>
+        <p:txBody>
+          <a:bodyPr/>
+          <a:p/>
+        </p:txBody>
       </p:sp>
       <p:sp>
         <p:nvSpPr>
@@ -4172,7 +4324,7 @@
             <a:r>
               <a:rPr lang="en-US" sz="1200" dirty="0">
                 <a:solidFill>
-                  <a:srgbClr val="666666"/>
+                  <a:srgbClr val="CDD6F4"/>
                 </a:solidFill>
               </a:rPr>
               <a:t>Game 1</a:t>
@@ -4186,7 +4338,7 @@
             <a:r>
               <a:rPr lang="en-US" sz="1200" dirty="0">
                 <a:solidFill>
-                  <a:srgbClr val="666666"/>
+                  <a:srgbClr val="CDD6F4"/>
                 </a:solidFill>
               </a:rPr>
               <a:t>(Image)</a:t>
@@ -4210,7 +4362,7 @@
             <a:avLst/>
           </a:prstGeom>
           <a:solidFill>
-            <a:srgbClr val="F5F5F5"/>
+            <a:srgbClr val="181825"/>
           </a:solidFill>
           <a:ln w="12700">
             <a:solidFill>
@@ -4219,6 +4371,10 @@
             <a:prstDash val="solid"/>
           </a:ln>
         </p:spPr>
+        <p:txBody>
+          <a:bodyPr/>
+          <a:p/>
+        </p:txBody>
       </p:sp>
       <p:sp>
         <p:nvSpPr>
@@ -4247,7 +4403,7 @@
             <a:r>
               <a:rPr lang="en-US" sz="1200" dirty="0">
                 <a:solidFill>
-                  <a:srgbClr val="666666"/>
+                  <a:srgbClr val="CDD6F4"/>
                 </a:solidFill>
               </a:rPr>
               <a:t>Game 2</a:t>
@@ -4261,7 +4417,7 @@
             <a:r>
               <a:rPr lang="en-US" sz="1200" dirty="0">
                 <a:solidFill>
-                  <a:srgbClr val="666666"/>
+                  <a:srgbClr val="CDD6F4"/>
                 </a:solidFill>
               </a:rPr>
               <a:t>(Image)</a:t>
@@ -4285,7 +4441,7 @@
             <a:avLst/>
           </a:prstGeom>
           <a:solidFill>
-            <a:srgbClr val="F5F5F5"/>
+            <a:srgbClr val="181825"/>
           </a:solidFill>
           <a:ln w="12700">
             <a:solidFill>
@@ -4294,6 +4450,10 @@
             <a:prstDash val="solid"/>
           </a:ln>
         </p:spPr>
+        <p:txBody>
+          <a:bodyPr/>
+          <a:p/>
+        </p:txBody>
       </p:sp>
       <p:sp>
         <p:nvSpPr>
@@ -4322,7 +4482,7 @@
             <a:r>
               <a:rPr lang="en-US" sz="1200" dirty="0">
                 <a:solidFill>
-                  <a:srgbClr val="666666"/>
+                  <a:srgbClr val="CDD6F4"/>
                 </a:solidFill>
               </a:rPr>
               <a:t>Game 3</a:t>
@@ -4336,7 +4496,7 @@
             <a:r>
               <a:rPr lang="en-US" sz="1200" dirty="0">
                 <a:solidFill>
-                  <a:srgbClr val="666666"/>
+                  <a:srgbClr val="CDD6F4"/>
                 </a:solidFill>
               </a:rPr>
               <a:t>(Image)</a:t>
@@ -4360,7 +4520,7 @@
             <a:avLst/>
           </a:prstGeom>
           <a:solidFill>
-            <a:srgbClr val="F5F5F5"/>
+            <a:srgbClr val="181825"/>
           </a:solidFill>
           <a:ln w="12700">
             <a:solidFill>
@@ -4369,6 +4529,10 @@
             <a:prstDash val="solid"/>
           </a:ln>
         </p:spPr>
+        <p:txBody>
+          <a:bodyPr/>
+          <a:p/>
+        </p:txBody>
       </p:sp>
       <p:sp>
         <p:nvSpPr>
@@ -4397,7 +4561,7 @@
             <a:r>
               <a:rPr lang="en-US" sz="1200" dirty="0">
                 <a:solidFill>
-                  <a:srgbClr val="666666"/>
+                  <a:srgbClr val="CDD6F4"/>
                 </a:solidFill>
               </a:rPr>
               <a:t>Game 4</a:t>
@@ -4411,7 +4575,7 @@
             <a:r>
               <a:rPr lang="en-US" sz="1200" dirty="0">
                 <a:solidFill>
-                  <a:srgbClr val="666666"/>
+                  <a:srgbClr val="CDD6F4"/>
                 </a:solidFill>
               </a:rPr>
               <a:t>(Image)</a:t>
@@ -4442,6 +4606,10 @@
             <a:prstDash val="solid"/>
           </a:ln>
         </p:spPr>
+        <p:txBody>
+          <a:bodyPr/>
+          <a:p/>
+        </p:txBody>
       </p:sp>
       <p:sp>
         <p:nvSpPr>
@@ -4470,7 +4638,7 @@
             <a:r>
               <a:rPr lang="en-US" sz="1000" dirty="0">
                 <a:solidFill>
-                  <a:srgbClr val="999999"/>
+                  <a:srgbClr val="CDD6F4"/>
                 </a:solidFill>
               </a:rPr>
               <a:t>Footer - Copyright © 2026 Nexus</a:t>
@@ -4490,6 +4658,14 @@
 <file path=ppt/slides/slide3.xml><?xml version="1.0" encoding="utf-8"?>
 <p:sld xmlns:a="http://schemas.openxmlformats.org/drawingml/2006/main" xmlns:r="http://schemas.openxmlformats.org/officeDocument/2006/relationships" xmlns:p="http://schemas.openxmlformats.org/presentationml/2006/main">
   <p:cSld name="Slide 3">
+    <p:bg>
+      <p:bgPr>
+        <a:solidFill>
+          <a:srgbClr val="1E1E2E"/>
+        </a:solidFill>
+        <a:effectLst/>
+      </p:bgPr>
+    </p:bg>
     <p:spTree>
       <p:nvGrpSpPr>
         <p:cNvPr id="1" name=""/>
@@ -4531,7 +4707,7 @@
             <a:r>
               <a:rPr lang="en-US" sz="1800" b="1" dirty="0">
                 <a:solidFill>
-                  <a:srgbClr val="363636"/>
+                  <a:srgbClr val="CDD6F4"/>
                 </a:solidFill>
               </a:rPr>
               <a:t>Nexus Tracker</a:t>
@@ -4567,7 +4743,7 @@
             <a:r>
               <a:rPr lang="en-US" sz="1400" dirty="0">
                 <a:solidFill>
-                  <a:srgbClr val="666666"/>
+                  <a:srgbClr val="CDD6F4"/>
                 </a:solidFill>
               </a:rPr>
               <a:t>[Catalog]  [Search]  [Logbook]  [Contact]</a:t>
@@ -4598,6 +4774,10 @@
             <a:prstDash val="solid"/>
           </a:ln>
         </p:spPr>
+        <p:txBody>
+          <a:bodyPr/>
+          <a:p/>
+        </p:txBody>
       </p:sp>
       <p:sp>
         <p:nvSpPr>
@@ -4626,7 +4806,7 @@
             <a:r>
               <a:rPr lang="en-US" sz="2400" b="1" dirty="0">
                 <a:solidFill>
-                  <a:srgbClr val="003366"/>
+                  <a:srgbClr val="CDD6F4"/>
                 </a:solidFill>
               </a:rPr>
               <a:t>Client Page 3: Search</a:t>
@@ -4650,7 +4830,7 @@
             <a:avLst/>
           </a:prstGeom>
           <a:solidFill>
-            <a:srgbClr val="FFFFFF"/>
+            <a:srgbClr val="181825"/>
           </a:solidFill>
           <a:ln w="12700">
             <a:solidFill>
@@ -4659,6 +4839,10 @@
             <a:prstDash val="solid"/>
           </a:ln>
         </p:spPr>
+        <p:txBody>
+          <a:bodyPr/>
+          <a:p/>
+        </p:txBody>
       </p:sp>
       <p:sp>
         <p:nvSpPr>
@@ -4687,7 +4871,7 @@
             <a:r>
               <a:rPr lang="en-US" sz="1200" dirty="0">
                 <a:solidFill>
-                  <a:srgbClr val="999999"/>
+                  <a:srgbClr val="CDD6F4"/>
                 </a:solidFill>
               </a:rPr>
               <a:t>Enter game title, genre...</a:t>
@@ -4711,10 +4895,14 @@
             <a:avLst/>
           </a:prstGeom>
           <a:solidFill>
-            <a:srgbClr val="0066CC"/>
+            <a:srgbClr val="181825"/>
           </a:solidFill>
           <a:ln/>
         </p:spPr>
+        <p:txBody>
+          <a:bodyPr/>
+          <a:p/>
+        </p:txBody>
       </p:sp>
       <p:sp>
         <p:nvSpPr>
@@ -4743,7 +4931,7 @@
             <a:r>
               <a:rPr lang="en-US" sz="1200" b="1" dirty="0">
                 <a:solidFill>
-                  <a:srgbClr val="FFFFFF"/>
+                  <a:srgbClr val="CDD6F4"/>
                 </a:solidFill>
               </a:rPr>
               <a:t>SEARCH</a:t>
@@ -4779,7 +4967,7 @@
             <a:r>
               <a:rPr lang="en-US" sz="1200" dirty="0">
                 <a:solidFill>
-                  <a:srgbClr val="333333"/>
+                  <a:srgbClr val="CDD6F4"/>
                 </a:solidFill>
               </a:rPr>
               <a:t>Filters: [ ] Action  [ ] RPG  [ ] Strategy</a:t>
@@ -4803,7 +4991,7 @@
             <a:avLst/>
           </a:prstGeom>
           <a:solidFill>
-            <a:srgbClr val="F9F9F9"/>
+            <a:srgbClr val="181825"/>
           </a:solidFill>
           <a:ln w="12700">
             <a:solidFill>
@@ -4812,6 +5000,10 @@
             <a:prstDash val="solid"/>
           </a:ln>
         </p:spPr>
+        <p:txBody>
+          <a:bodyPr/>
+          <a:p/>
+        </p:txBody>
       </p:sp>
       <p:sp>
         <p:nvSpPr>
@@ -4840,7 +5032,7 @@
             <a:r>
               <a:rPr lang="en-US" sz="1400" dirty="0">
                 <a:solidFill>
-                  <a:srgbClr val="000000"/>
+                  <a:srgbClr val="CDD6F4"/>
                 </a:solidFill>
               </a:rPr>
               <a:t>[IMG] Title: Cyber-Odyssey | Platform: PC | Year: 2026</a:t>
@@ -4871,6 +5063,10 @@
             <a:prstDash val="solid"/>
           </a:ln>
         </p:spPr>
+        <p:txBody>
+          <a:bodyPr/>
+          <a:p/>
+        </p:txBody>
       </p:sp>
       <p:sp>
         <p:nvSpPr>
@@ -4899,7 +5095,7 @@
             <a:r>
               <a:rPr lang="en-US" sz="1000" dirty="0">
                 <a:solidFill>
-                  <a:srgbClr val="999999"/>
+                  <a:srgbClr val="CDD6F4"/>
                 </a:solidFill>
               </a:rPr>
               <a:t>Footer - Copyright © 2026 Nexus</a:t>
@@ -4919,6 +5115,14 @@
 <file path=ppt/slides/slide4.xml><?xml version="1.0" encoding="utf-8"?>
 <p:sld xmlns:a="http://schemas.openxmlformats.org/drawingml/2006/main" xmlns:r="http://schemas.openxmlformats.org/officeDocument/2006/relationships" xmlns:p="http://schemas.openxmlformats.org/presentationml/2006/main">
   <p:cSld name="Slide 4">
+    <p:bg>
+      <p:bgPr>
+        <a:solidFill>
+          <a:srgbClr val="1E1E2E"/>
+        </a:solidFill>
+        <a:effectLst/>
+      </p:bgPr>
+    </p:bg>
     <p:spTree>
       <p:nvGrpSpPr>
         <p:cNvPr id="1" name=""/>
@@ -4960,7 +5164,7 @@
             <a:r>
               <a:rPr lang="en-US" sz="1800" b="1" dirty="0">
                 <a:solidFill>
-                  <a:srgbClr val="363636"/>
+                  <a:srgbClr val="CDD6F4"/>
                 </a:solidFill>
               </a:rPr>
               <a:t>Nexus Tracker</a:t>
@@ -4996,7 +5200,7 @@
             <a:r>
               <a:rPr lang="en-US" sz="1400" dirty="0">
                 <a:solidFill>
-                  <a:srgbClr val="666666"/>
+                  <a:srgbClr val="CDD6F4"/>
                 </a:solidFill>
               </a:rPr>
               <a:t>[Catalog]  [Search]  [Logbook]  [Contact]</a:t>
@@ -5027,6 +5231,10 @@
             <a:prstDash val="solid"/>
           </a:ln>
         </p:spPr>
+        <p:txBody>
+          <a:bodyPr/>
+          <a:p/>
+        </p:txBody>
       </p:sp>
       <p:sp>
         <p:nvSpPr>
@@ -5055,7 +5263,7 @@
             <a:r>
               <a:rPr lang="en-US" sz="2400" b="1" dirty="0">
                 <a:solidFill>
-                  <a:srgbClr val="003366"/>
+                  <a:srgbClr val="CDD6F4"/>
                 </a:solidFill>
               </a:rPr>
               <a:t>Client Page 4: Logbook</a:t>
@@ -5079,7 +5287,7 @@
             <a:avLst/>
           </a:prstGeom>
           <a:solidFill>
-            <a:srgbClr val="FFFFFF"/>
+            <a:srgbClr val="181825"/>
           </a:solidFill>
           <a:ln w="12700">
             <a:solidFill>
@@ -5088,6 +5296,10 @@
             <a:prstDash val="solid"/>
           </a:ln>
         </p:spPr>
+        <p:txBody>
+          <a:bodyPr/>
+          <a:p/>
+        </p:txBody>
       </p:sp>
       <p:sp>
         <p:nvSpPr>
@@ -5116,7 +5328,7 @@
             <a:r>
               <a:rPr lang="en-US" sz="1200" b="1" dirty="0">
                 <a:solidFill>
-                  <a:srgbClr val="000000"/>
+                  <a:srgbClr val="CDD6F4"/>
                 </a:solidFill>
               </a:rPr>
               <a:t>Title                  Platform      Status          Rating     Action</a:t>
@@ -5147,6 +5359,10 @@
             <a:prstDash val="solid"/>
           </a:ln>
         </p:spPr>
+        <p:txBody>
+          <a:bodyPr/>
+          <a:p/>
+        </p:txBody>
       </p:sp>
       <p:sp>
         <p:nvSpPr>
@@ -5175,7 +5391,7 @@
             <a:r>
               <a:rPr lang="en-US" sz="1200" dirty="0">
                 <a:solidFill>
-                  <a:srgbClr val="000000"/>
+                  <a:srgbClr val="CDD6F4"/>
                 </a:solidFill>
               </a:rPr>
               <a:t>Final Fantasy          PS5           Playing         5/5        [Edit]</a:t>
@@ -5211,7 +5427,7 @@
             <a:r>
               <a:rPr lang="en-US" sz="1200" dirty="0">
                 <a:solidFill>
-                  <a:srgbClr val="000000"/>
+                  <a:srgbClr val="CDD6F4"/>
                 </a:solidFill>
               </a:rPr>
               <a:t>Halo Infinite          Xbox          Completed       4/5        [Edit]</a:t>
@@ -5247,7 +5463,7 @@
             <a:r>
               <a:rPr lang="en-US" sz="1200" dirty="0">
                 <a:solidFill>
-                  <a:srgbClr val="000000"/>
+                  <a:srgbClr val="CDD6F4"/>
                 </a:solidFill>
               </a:rPr>
               <a:t>Factorio               PC            Backlog         N/A        [Edit]</a:t>
@@ -5278,6 +5494,10 @@
             <a:prstDash val="solid"/>
           </a:ln>
         </p:spPr>
+        <p:txBody>
+          <a:bodyPr/>
+          <a:p/>
+        </p:txBody>
       </p:sp>
       <p:sp>
         <p:nvSpPr>
@@ -5306,7 +5526,7 @@
             <a:r>
               <a:rPr lang="en-US" sz="1000" dirty="0">
                 <a:solidFill>
-                  <a:srgbClr val="999999"/>
+                  <a:srgbClr val="CDD6F4"/>
                 </a:solidFill>
               </a:rPr>
               <a:t>Footer - Copyright © 2026 Nexus</a:t>
@@ -5326,6 +5546,14 @@
 <file path=ppt/slides/slide5.xml><?xml version="1.0" encoding="utf-8"?>
 <p:sld xmlns:a="http://schemas.openxmlformats.org/drawingml/2006/main" xmlns:r="http://schemas.openxmlformats.org/officeDocument/2006/relationships" xmlns:p="http://schemas.openxmlformats.org/presentationml/2006/main">
   <p:cSld name="Slide 5">
+    <p:bg>
+      <p:bgPr>
+        <a:solidFill>
+          <a:srgbClr val="1E1E2E"/>
+        </a:solidFill>
+        <a:effectLst/>
+      </p:bgPr>
+    </p:bg>
     <p:spTree>
       <p:nvGrpSpPr>
         <p:cNvPr id="1" name=""/>
@@ -5367,7 +5595,7 @@
             <a:r>
               <a:rPr lang="en-US" sz="1800" b="1" dirty="0">
                 <a:solidFill>
-                  <a:srgbClr val="363636"/>
+                  <a:srgbClr val="CDD6F4"/>
                 </a:solidFill>
               </a:rPr>
               <a:t>Nexus Tracker</a:t>
@@ -5403,7 +5631,7 @@
             <a:r>
               <a:rPr lang="en-US" sz="1400" dirty="0">
                 <a:solidFill>
-                  <a:srgbClr val="666666"/>
+                  <a:srgbClr val="CDD6F4"/>
                 </a:solidFill>
               </a:rPr>
               <a:t>[Catalog]  [Search]  [Logbook]  [Contact]</a:t>
@@ -5434,6 +5662,10 @@
             <a:prstDash val="solid"/>
           </a:ln>
         </p:spPr>
+        <p:txBody>
+          <a:bodyPr/>
+          <a:p/>
+        </p:txBody>
       </p:sp>
       <p:sp>
         <p:nvSpPr>
@@ -5462,7 +5694,7 @@
             <a:r>
               <a:rPr lang="en-US" sz="2400" b="1" dirty="0">
                 <a:solidFill>
-                  <a:srgbClr val="003366"/>
+                  <a:srgbClr val="CDD6F4"/>
                 </a:solidFill>
               </a:rPr>
               <a:t>Client Page 5: Contact</a:t>
@@ -5498,7 +5730,7 @@
             <a:r>
               <a:rPr lang="en-US" sz="1600" b="1" dirty="0">
                 <a:solidFill>
-                  <a:srgbClr val="000000"/>
+                  <a:srgbClr val="CDD6F4"/>
                 </a:solidFill>
               </a:rPr>
               <a:t>Contact Support</a:t>
@@ -5534,7 +5766,7 @@
             <a:r>
               <a:rPr lang="en-US" sz="1200" dirty="0">
                 <a:solidFill>
-                  <a:srgbClr val="000000"/>
+                  <a:srgbClr val="CDD6F4"/>
                 </a:solidFill>
               </a:rPr>
               <a:t>Name:</a:t>
@@ -5558,7 +5790,7 @@
             <a:avLst/>
           </a:prstGeom>
           <a:solidFill>
-            <a:srgbClr val="FFFFFF"/>
+            <a:srgbClr val="181825"/>
           </a:solidFill>
           <a:ln w="12700">
             <a:solidFill>
@@ -5567,6 +5799,10 @@
             <a:prstDash val="solid"/>
           </a:ln>
         </p:spPr>
+        <p:txBody>
+          <a:bodyPr/>
+          <a:p/>
+        </p:txBody>
       </p:sp>
       <p:sp>
         <p:nvSpPr>
@@ -5595,7 +5831,7 @@
             <a:r>
               <a:rPr lang="en-US" sz="1200" dirty="0">
                 <a:solidFill>
-                  <a:srgbClr val="000000"/>
+                  <a:srgbClr val="CDD6F4"/>
                 </a:solidFill>
               </a:rPr>
               <a:t>Email:</a:t>
@@ -5619,7 +5855,7 @@
             <a:avLst/>
           </a:prstGeom>
           <a:solidFill>
-            <a:srgbClr val="FFFFFF"/>
+            <a:srgbClr val="181825"/>
           </a:solidFill>
           <a:ln w="12700">
             <a:solidFill>
@@ -5628,6 +5864,10 @@
             <a:prstDash val="solid"/>
           </a:ln>
         </p:spPr>
+        <p:txBody>
+          <a:bodyPr/>
+          <a:p/>
+        </p:txBody>
       </p:sp>
       <p:sp>
         <p:nvSpPr>
@@ -5656,7 +5896,7 @@
             <a:r>
               <a:rPr lang="en-US" sz="1200" dirty="0">
                 <a:solidFill>
-                  <a:srgbClr val="000000"/>
+                  <a:srgbClr val="CDD6F4"/>
                 </a:solidFill>
               </a:rPr>
               <a:t>Message:</a:t>
@@ -5680,7 +5920,7 @@
             <a:avLst/>
           </a:prstGeom>
           <a:solidFill>
-            <a:srgbClr val="FFFFFF"/>
+            <a:srgbClr val="181825"/>
           </a:solidFill>
           <a:ln w="12700">
             <a:solidFill>
@@ -5689,6 +5929,10 @@
             <a:prstDash val="solid"/>
           </a:ln>
         </p:spPr>
+        <p:txBody>
+          <a:bodyPr/>
+          <a:p/>
+        </p:txBody>
       </p:sp>
       <p:sp>
         <p:nvSpPr>
@@ -5705,10 +5949,14 @@
             <a:avLst/>
           </a:prstGeom>
           <a:solidFill>
-            <a:srgbClr val="0066CC"/>
+            <a:srgbClr val="181825"/>
           </a:solidFill>
           <a:ln/>
         </p:spPr>
+        <p:txBody>
+          <a:bodyPr/>
+          <a:p/>
+        </p:txBody>
       </p:sp>
       <p:sp>
         <p:nvSpPr>
@@ -5737,7 +5985,7 @@
             <a:r>
               <a:rPr lang="en-US" sz="1200" b="1" dirty="0">
                 <a:solidFill>
-                  <a:srgbClr val="FFFFFF"/>
+                  <a:srgbClr val="CDD6F4"/>
                 </a:solidFill>
               </a:rPr>
               <a:t>SUBMIT</a:t>
@@ -5768,6 +6016,10 @@
             <a:prstDash val="solid"/>
           </a:ln>
         </p:spPr>
+        <p:txBody>
+          <a:bodyPr/>
+          <a:p/>
+        </p:txBody>
       </p:sp>
       <p:sp>
         <p:nvSpPr>
@@ -5796,7 +6048,7 @@
             <a:r>
               <a:rPr lang="en-US" sz="1000" dirty="0">
                 <a:solidFill>
-                  <a:srgbClr val="999999"/>
+                  <a:srgbClr val="CDD6F4"/>
                 </a:solidFill>
               </a:rPr>
               <a:t>Footer - Copyright © 2026 Nexus</a:t>
@@ -5816,6 +6068,14 @@
 <file path=ppt/slides/slide6.xml><?xml version="1.0" encoding="utf-8"?>
 <p:sld xmlns:a="http://schemas.openxmlformats.org/drawingml/2006/main" xmlns:r="http://schemas.openxmlformats.org/officeDocument/2006/relationships" xmlns:p="http://schemas.openxmlformats.org/presentationml/2006/main">
   <p:cSld name="Slide 6">
+    <p:bg>
+      <p:bgPr>
+        <a:solidFill>
+          <a:srgbClr val="1E1E2E"/>
+        </a:solidFill>
+        <a:effectLst/>
+      </p:bgPr>
+    </p:bg>
     <p:spTree>
       <p:nvGrpSpPr>
         <p:cNvPr id="1" name=""/>
@@ -5857,7 +6117,7 @@
             <a:r>
               <a:rPr lang="en-US" sz="1800" b="1" dirty="0">
                 <a:solidFill>
-                  <a:srgbClr val="363636"/>
+                  <a:srgbClr val="CDD6F4"/>
                 </a:solidFill>
               </a:rPr>
               <a:t>Nexus Tracker</a:t>
@@ -5893,7 +6153,7 @@
             <a:r>
               <a:rPr lang="en-US" sz="1400" dirty="0">
                 <a:solidFill>
-                  <a:srgbClr val="666666"/>
+                  <a:srgbClr val="CDD6F4"/>
                 </a:solidFill>
               </a:rPr>
               <a:t>[Catalog]  [Search]  [Logbook]  [Contact]</a:t>
@@ -5924,6 +6184,10 @@
             <a:prstDash val="solid"/>
           </a:ln>
         </p:spPr>
+        <p:txBody>
+          <a:bodyPr/>
+          <a:p/>
+        </p:txBody>
       </p:sp>
       <p:sp>
         <p:nvSpPr>
@@ -5952,7 +6216,7 @@
             <a:r>
               <a:rPr lang="en-US" sz="2400" b="1" dirty="0">
                 <a:solidFill>
-                  <a:srgbClr val="003366"/>
+                  <a:srgbClr val="CDD6F4"/>
                 </a:solidFill>
               </a:rPr>
               <a:t>Client Page 6: Profile</a:t>
@@ -5976,7 +6240,7 @@
             <a:avLst/>
           </a:prstGeom>
           <a:solidFill>
-            <a:srgbClr val="EAEAEA"/>
+            <a:srgbClr val="181825"/>
           </a:solidFill>
           <a:ln w="12700">
             <a:solidFill>
@@ -5985,6 +6249,10 @@
             <a:prstDash val="solid"/>
           </a:ln>
         </p:spPr>
+        <p:txBody>
+          <a:bodyPr/>
+          <a:p/>
+        </p:txBody>
       </p:sp>
       <p:sp>
         <p:nvSpPr>
@@ -6013,7 +6281,7 @@
             <a:r>
               <a:rPr lang="en-US" sz="1200" dirty="0">
                 <a:solidFill>
-                  <a:srgbClr val="666666"/>
+                  <a:srgbClr val="CDD6F4"/>
                 </a:solidFill>
               </a:rPr>
               <a:t>Avatar</a:t>
@@ -6049,7 +6317,7 @@
             <a:r>
               <a:rPr lang="en-US" sz="1600" b="1" dirty="0">
                 <a:solidFill>
-                  <a:srgbClr val="000000"/>
+                  <a:srgbClr val="CDD6F4"/>
                 </a:solidFill>
               </a:rPr>
               <a:t>User: PlayerOne</a:t>
@@ -6085,7 +6353,7 @@
             <a:r>
               <a:rPr lang="en-US" sz="1200" dirty="0">
                 <a:solidFill>
-                  <a:srgbClr val="000000"/>
+                  <a:srgbClr val="CDD6F4"/>
                 </a:solidFill>
               </a:rPr>
               <a:t>Total Games: 142</a:t>
@@ -6121,7 +6389,7 @@
             <a:r>
               <a:rPr lang="en-US" sz="1200" dirty="0">
                 <a:solidFill>
-                  <a:srgbClr val="000000"/>
+                  <a:srgbClr val="CDD6F4"/>
                 </a:solidFill>
               </a:rPr>
               <a:t>Hours Played: 5,420</a:t>
@@ -6145,7 +6413,7 @@
             <a:avLst/>
           </a:prstGeom>
           <a:solidFill>
-            <a:srgbClr val="F9F9F9"/>
+            <a:srgbClr val="181825"/>
           </a:solidFill>
           <a:ln w="12700">
             <a:solidFill>
@@ -6154,6 +6422,10 @@
             <a:prstDash val="solid"/>
           </a:ln>
         </p:spPr>
+        <p:txBody>
+          <a:bodyPr/>
+          <a:p/>
+        </p:txBody>
       </p:sp>
       <p:sp>
         <p:nvSpPr>
@@ -6182,7 +6454,7 @@
             <a:r>
               <a:rPr lang="en-US" sz="1400" dirty="0">
                 <a:solidFill>
-                  <a:srgbClr val="999999"/>
+                  <a:srgbClr val="CDD6F4"/>
                 </a:solidFill>
               </a:rPr>
               <a:t>Favorite Genres Chart Placeholder</a:t>
@@ -6213,6 +6485,10 @@
             <a:prstDash val="solid"/>
           </a:ln>
         </p:spPr>
+        <p:txBody>
+          <a:bodyPr/>
+          <a:p/>
+        </p:txBody>
       </p:sp>
       <p:sp>
         <p:nvSpPr>
@@ -6241,7 +6517,7 @@
             <a:r>
               <a:rPr lang="en-US" sz="1000" dirty="0">
                 <a:solidFill>
-                  <a:srgbClr val="999999"/>
+                  <a:srgbClr val="CDD6F4"/>
                 </a:solidFill>
               </a:rPr>
               <a:t>Footer - Copyright © 2026 Nexus</a:t>
@@ -6261,6 +6537,14 @@
 <file path=ppt/slides/slide7.xml><?xml version="1.0" encoding="utf-8"?>
 <p:sld xmlns:a="http://schemas.openxmlformats.org/drawingml/2006/main" xmlns:r="http://schemas.openxmlformats.org/officeDocument/2006/relationships" xmlns:p="http://schemas.openxmlformats.org/presentationml/2006/main">
   <p:cSld name="Slide 7">
+    <p:bg>
+      <p:bgPr>
+        <a:solidFill>
+          <a:srgbClr val="1E1E2E"/>
+        </a:solidFill>
+        <a:effectLst/>
+      </p:bgPr>
+    </p:bg>
     <p:spTree>
       <p:nvGrpSpPr>
         <p:cNvPr id="1" name=""/>
@@ -6302,7 +6586,7 @@
             <a:r>
               <a:rPr lang="en-US" sz="1800" b="1" dirty="0">
                 <a:solidFill>
-                  <a:srgbClr val="363636"/>
+                  <a:srgbClr val="CDD6F4"/>
                 </a:solidFill>
               </a:rPr>
               <a:t>Nexus Tracker</a:t>
@@ -6338,7 +6622,7 @@
             <a:r>
               <a:rPr lang="en-US" sz="1400" dirty="0">
                 <a:solidFill>
-                  <a:srgbClr val="666666"/>
+                  <a:srgbClr val="CDD6F4"/>
                 </a:solidFill>
               </a:rPr>
               <a:t>[Catalog]  [Search]  [Logbook]  [Contact]</a:t>
@@ -6369,6 +6653,10 @@
             <a:prstDash val="solid"/>
           </a:ln>
         </p:spPr>
+        <p:txBody>
+          <a:bodyPr/>
+          <a:p/>
+        </p:txBody>
       </p:sp>
       <p:sp>
         <p:nvSpPr>
@@ -6397,7 +6685,7 @@
             <a:r>
               <a:rPr lang="en-US" sz="2400" b="1" dirty="0">
                 <a:solidFill>
-                  <a:srgbClr val="003366"/>
+                  <a:srgbClr val="CDD6F4"/>
                 </a:solidFill>
               </a:rPr>
               <a:t>Client Page 7: Login</a:t>
@@ -6421,7 +6709,7 @@
             <a:avLst/>
           </a:prstGeom>
           <a:solidFill>
-            <a:srgbClr val="F5F5F5"/>
+            <a:srgbClr val="181825"/>
           </a:solidFill>
           <a:ln w="12700">
             <a:solidFill>
@@ -6430,6 +6718,10 @@
             <a:prstDash val="solid"/>
           </a:ln>
         </p:spPr>
+        <p:txBody>
+          <a:bodyPr/>
+          <a:p/>
+        </p:txBody>
       </p:sp>
       <p:sp>
         <p:nvSpPr>
@@ -6458,7 +6750,7 @@
             <a:r>
               <a:rPr lang="en-US" sz="1200" dirty="0">
                 <a:solidFill>
-                  <a:srgbClr val="000000"/>
+                  <a:srgbClr val="CDD6F4"/>
                 </a:solidFill>
               </a:rPr>
               <a:t>Sign In</a:t>
@@ -6472,7 +6764,7 @@
             <a:r>
               <a:rPr lang="en-US" sz="1200" dirty="0">
                 <a:solidFill>
-                  <a:srgbClr val="000000"/>
+                  <a:srgbClr val="CDD6F4"/>
                 </a:solidFill>
               </a:rPr>
               <a:t>[Username]</a:t>
@@ -6486,7 +6778,7 @@
             <a:r>
               <a:rPr lang="en-US" sz="1200" dirty="0">
                 <a:solidFill>
-                  <a:srgbClr val="000000"/>
+                  <a:srgbClr val="CDD6F4"/>
                 </a:solidFill>
               </a:rPr>
               <a:t>[Password]</a:t>
@@ -6500,7 +6792,7 @@
             <a:r>
               <a:rPr lang="en-US" sz="1200" dirty="0">
                 <a:solidFill>
-                  <a:srgbClr val="000000"/>
+                  <a:srgbClr val="CDD6F4"/>
                 </a:solidFill>
               </a:rPr>
               <a:t>[LOGIN]</a:t>
@@ -6524,7 +6816,7 @@
             <a:avLst/>
           </a:prstGeom>
           <a:solidFill>
-            <a:srgbClr val="F5F5F5"/>
+            <a:srgbClr val="181825"/>
           </a:solidFill>
           <a:ln w="12700">
             <a:solidFill>
@@ -6533,6 +6825,10 @@
             <a:prstDash val="solid"/>
           </a:ln>
         </p:spPr>
+        <p:txBody>
+          <a:bodyPr/>
+          <a:p/>
+        </p:txBody>
       </p:sp>
       <p:sp>
         <p:nvSpPr>
@@ -6561,7 +6857,7 @@
             <a:r>
               <a:rPr lang="en-US" sz="1200" dirty="0">
                 <a:solidFill>
-                  <a:srgbClr val="000000"/>
+                  <a:srgbClr val="CDD6F4"/>
                 </a:solidFill>
               </a:rPr>
               <a:t>Sign Up</a:t>
@@ -6575,7 +6871,7 @@
             <a:r>
               <a:rPr lang="en-US" sz="1200" dirty="0">
                 <a:solidFill>
-                  <a:srgbClr val="000000"/>
+                  <a:srgbClr val="CDD6F4"/>
                 </a:solidFill>
               </a:rPr>
               <a:t>[Username]</a:t>
@@ -6589,7 +6885,7 @@
             <a:r>
               <a:rPr lang="en-US" sz="1200" dirty="0">
                 <a:solidFill>
-                  <a:srgbClr val="000000"/>
+                  <a:srgbClr val="CDD6F4"/>
                 </a:solidFill>
               </a:rPr>
               <a:t>[Password]</a:t>
@@ -6603,7 +6899,7 @@
             <a:r>
               <a:rPr lang="en-US" sz="1200" dirty="0">
                 <a:solidFill>
-                  <a:srgbClr val="000000"/>
+                  <a:srgbClr val="CDD6F4"/>
                 </a:solidFill>
               </a:rPr>
               <a:t>[REGISTER]</a:t>
@@ -6634,6 +6930,10 @@
             <a:prstDash val="solid"/>
           </a:ln>
         </p:spPr>
+        <p:txBody>
+          <a:bodyPr/>
+          <a:p/>
+        </p:txBody>
       </p:sp>
       <p:sp>
         <p:nvSpPr>
@@ -6662,7 +6962,7 @@
             <a:r>
               <a:rPr lang="en-US" sz="1000" dirty="0">
                 <a:solidFill>
-                  <a:srgbClr val="999999"/>
+                  <a:srgbClr val="CDD6F4"/>
                 </a:solidFill>
               </a:rPr>
               <a:t>Footer - Copyright © 2026 Nexus</a:t>
@@ -6682,6 +6982,14 @@
 <file path=ppt/slides/slide8.xml><?xml version="1.0" encoding="utf-8"?>
 <p:sld xmlns:a="http://schemas.openxmlformats.org/drawingml/2006/main" xmlns:r="http://schemas.openxmlformats.org/officeDocument/2006/relationships" xmlns:p="http://schemas.openxmlformats.org/presentationml/2006/main">
   <p:cSld name="Slide 8">
+    <p:bg>
+      <p:bgPr>
+        <a:solidFill>
+          <a:srgbClr val="1E1E2E"/>
+        </a:solidFill>
+        <a:effectLst/>
+      </p:bgPr>
+    </p:bg>
     <p:spTree>
       <p:nvGrpSpPr>
         <p:cNvPr id="1" name=""/>
@@ -6711,10 +7019,14 @@
             <a:avLst/>
           </a:prstGeom>
           <a:solidFill>
-            <a:srgbClr val="222222"/>
+            <a:srgbClr val="181825"/>
           </a:solidFill>
           <a:ln/>
         </p:spPr>
+        <p:txBody>
+          <a:bodyPr/>
+          <a:p/>
+        </p:txBody>
       </p:sp>
       <p:sp>
         <p:nvSpPr>
@@ -6743,7 +7055,7 @@
             <a:r>
               <a:rPr lang="en-US" sz="1600" b="1" dirty="0">
                 <a:solidFill>
-                  <a:srgbClr val="FFFFFF"/>
+                  <a:srgbClr val="CDD6F4"/>
                 </a:solidFill>
               </a:rPr>
               <a:t>Nexus ADMIN</a:t>
@@ -6779,7 +7091,7 @@
             <a:r>
               <a:rPr lang="en-US" sz="1100" dirty="0">
                 <a:solidFill>
-                  <a:srgbClr val="CCCCCC"/>
+                  <a:srgbClr val="CDD6F4"/>
                 </a:solidFill>
               </a:rPr>
               <a:t>[Dashboard] [Games] [Users] [Analytics] [Inbox] [Logs] [Settings]</a:t>
@@ -6815,7 +7127,7 @@
             <a:r>
               <a:rPr lang="en-US" sz="2000" b="1" dirty="0">
                 <a:solidFill>
-                  <a:srgbClr val="000000"/>
+                  <a:srgbClr val="CDD6F4"/>
                 </a:solidFill>
               </a:rPr>
               <a:t>Admin Page 1: Dashboard</a:t>
@@ -6839,7 +7151,7 @@
             <a:avLst/>
           </a:prstGeom>
           <a:solidFill>
-            <a:srgbClr val="EFEFEF"/>
+            <a:srgbClr val="181825"/>
           </a:solidFill>
           <a:ln w="12700">
             <a:solidFill>
@@ -6848,6 +7160,10 @@
             <a:prstDash val="solid"/>
           </a:ln>
         </p:spPr>
+        <p:txBody>
+          <a:bodyPr/>
+          <a:p/>
+        </p:txBody>
       </p:sp>
       <p:sp>
         <p:nvSpPr>
@@ -6876,7 +7192,7 @@
             <a:r>
               <a:rPr lang="en-US" sz="1400" b="1" dirty="0">
                 <a:solidFill>
-                  <a:srgbClr val="000000"/>
+                  <a:srgbClr val="CDD6F4"/>
                 </a:solidFill>
               </a:rPr>
               <a:t>Total Games</a:t>
@@ -6890,7 +7206,7 @@
             <a:r>
               <a:rPr lang="en-US" sz="1400" b="1" dirty="0">
                 <a:solidFill>
-                  <a:srgbClr val="000000"/>
+                  <a:srgbClr val="CDD6F4"/>
                 </a:solidFill>
               </a:rPr>
               <a:t>1,204</a:t>
@@ -6914,7 +7230,7 @@
             <a:avLst/>
           </a:prstGeom>
           <a:solidFill>
-            <a:srgbClr val="EFEFEF"/>
+            <a:srgbClr val="181825"/>
           </a:solidFill>
           <a:ln w="12700">
             <a:solidFill>
@@ -6923,6 +7239,10 @@
             <a:prstDash val="solid"/>
           </a:ln>
         </p:spPr>
+        <p:txBody>
+          <a:bodyPr/>
+          <a:p/>
+        </p:txBody>
       </p:sp>
       <p:sp>
         <p:nvSpPr>
@@ -6951,7 +7271,7 @@
             <a:r>
               <a:rPr lang="en-US" sz="1400" b="1" dirty="0">
                 <a:solidFill>
-                  <a:srgbClr val="000000"/>
+                  <a:srgbClr val="CDD6F4"/>
                 </a:solidFill>
               </a:rPr>
               <a:t>Active Users</a:t>
@@ -6965,7 +7285,7 @@
             <a:r>
               <a:rPr lang="en-US" sz="1400" b="1" dirty="0">
                 <a:solidFill>
-                  <a:srgbClr val="000000"/>
+                  <a:srgbClr val="CDD6F4"/>
                 </a:solidFill>
               </a:rPr>
               <a:t>342</a:t>
@@ -6989,7 +7309,7 @@
             <a:avLst/>
           </a:prstGeom>
           <a:solidFill>
-            <a:srgbClr val="EFEFEF"/>
+            <a:srgbClr val="181825"/>
           </a:solidFill>
           <a:ln w="12700">
             <a:solidFill>
@@ -6998,6 +7318,10 @@
             <a:prstDash val="solid"/>
           </a:ln>
         </p:spPr>
+        <p:txBody>
+          <a:bodyPr/>
+          <a:p/>
+        </p:txBody>
       </p:sp>
       <p:sp>
         <p:nvSpPr>
@@ -7026,7 +7350,7 @@
             <a:r>
               <a:rPr lang="en-US" sz="1400" b="1" dirty="0">
                 <a:solidFill>
-                  <a:srgbClr val="000000"/>
+                  <a:srgbClr val="CDD6F4"/>
                 </a:solidFill>
               </a:rPr>
               <a:t>Server Status</a:t>
@@ -7040,7 +7364,7 @@
             <a:r>
               <a:rPr lang="en-US" sz="1400" b="1" dirty="0">
                 <a:solidFill>
-                  <a:srgbClr val="000000"/>
+                  <a:srgbClr val="CDD6F4"/>
                 </a:solidFill>
               </a:rPr>
               <a:t>Online</a:t>
@@ -7071,6 +7395,10 @@
             <a:prstDash val="solid"/>
           </a:ln>
         </p:spPr>
+        <p:txBody>
+          <a:bodyPr/>
+          <a:p/>
+        </p:txBody>
       </p:sp>
       <p:sp>
         <p:nvSpPr>
@@ -7099,7 +7427,7 @@
             <a:r>
               <a:rPr lang="en-US" sz="1000" dirty="0">
                 <a:solidFill>
-                  <a:srgbClr val="999999"/>
+                  <a:srgbClr val="CDD6F4"/>
                 </a:solidFill>
               </a:rPr>
               <a:t>Footer - Copyright © 2026 Nexus</a:t>
@@ -7119,6 +7447,14 @@
 <file path=ppt/slides/slide9.xml><?xml version="1.0" encoding="utf-8"?>
 <p:sld xmlns:a="http://schemas.openxmlformats.org/drawingml/2006/main" xmlns:r="http://schemas.openxmlformats.org/officeDocument/2006/relationships" xmlns:p="http://schemas.openxmlformats.org/presentationml/2006/main">
   <p:cSld name="Slide 9">
+    <p:bg>
+      <p:bgPr>
+        <a:solidFill>
+          <a:srgbClr val="1E1E2E"/>
+        </a:solidFill>
+        <a:effectLst/>
+      </p:bgPr>
+    </p:bg>
     <p:spTree>
       <p:nvGrpSpPr>
         <p:cNvPr id="1" name=""/>
@@ -7148,10 +7484,14 @@
             <a:avLst/>
           </a:prstGeom>
           <a:solidFill>
-            <a:srgbClr val="222222"/>
+            <a:srgbClr val="181825"/>
           </a:solidFill>
           <a:ln/>
         </p:spPr>
+        <p:txBody>
+          <a:bodyPr/>
+          <a:p/>
+        </p:txBody>
       </p:sp>
       <p:sp>
         <p:nvSpPr>
@@ -7180,7 +7520,7 @@
             <a:r>
               <a:rPr lang="en-US" sz="1600" b="1" dirty="0">
                 <a:solidFill>
-                  <a:srgbClr val="FFFFFF"/>
+                  <a:srgbClr val="CDD6F4"/>
                 </a:solidFill>
               </a:rPr>
               <a:t>Nexus ADMIN</a:t>
@@ -7216,7 +7556,7 @@
             <a:r>
               <a:rPr lang="en-US" sz="1100" dirty="0">
                 <a:solidFill>
-                  <a:srgbClr val="CCCCCC"/>
+                  <a:srgbClr val="CDD6F4"/>
                 </a:solidFill>
               </a:rPr>
               <a:t>[Dashboard] [Games] [Users] [Analytics] [Inbox] [Logs] [Settings]</a:t>
@@ -7252,7 +7592,7 @@
             <a:r>
               <a:rPr lang="en-US" sz="2000" b="1" dirty="0">
                 <a:solidFill>
-                  <a:srgbClr val="000000"/>
+                  <a:srgbClr val="CDD6F4"/>
                 </a:solidFill>
               </a:rPr>
               <a:t>Admin Page 2: Games Management</a:t>
@@ -7276,7 +7616,7 @@
             <a:avLst/>
           </a:prstGeom>
           <a:solidFill>
-            <a:srgbClr val="FFFFFF"/>
+            <a:srgbClr val="181825"/>
           </a:solidFill>
           <a:ln w="12700">
             <a:solidFill>
@@ -7285,6 +7625,10 @@
             <a:prstDash val="solid"/>
           </a:ln>
         </p:spPr>
+        <p:txBody>
+          <a:bodyPr/>
+          <a:p/>
+        </p:txBody>
       </p:sp>
       <p:sp>
         <p:nvSpPr>
@@ -7313,7 +7657,7 @@
             <a:r>
               <a:rPr lang="en-US" sz="1200" b="1" dirty="0">
                 <a:solidFill>
-                  <a:srgbClr val="000000"/>
+                  <a:srgbClr val="CDD6F4"/>
                 </a:solidFill>
               </a:rPr>
               <a:t>ID     Title                     Genre       Platform      Actions</a:t>
@@ -7344,6 +7688,10 @@
             <a:prstDash val="solid"/>
           </a:ln>
         </p:spPr>
+        <p:txBody>
+          <a:bodyPr/>
+          <a:p/>
+        </p:txBody>
       </p:sp>
       <p:sp>
         <p:nvSpPr>
@@ -7372,7 +7720,7 @@
             <a:r>
               <a:rPr lang="en-US" sz="1200" dirty="0">
                 <a:solidFill>
-                  <a:srgbClr val="000000"/>
+                  <a:srgbClr val="CDD6F4"/>
                 </a:solidFill>
               </a:rPr>
               <a:t>1      Cyber-Odyssey             Action      PC, PS5       [Edit] [Del]</a:t>
@@ -7403,6 +7751,10 @@
             <a:prstDash val="solid"/>
           </a:ln>
         </p:spPr>
+        <p:txBody>
+          <a:bodyPr/>
+          <a:p/>
+        </p:txBody>
       </p:sp>
       <p:sp>
         <p:nvSpPr>
@@ -7431,7 +7783,7 @@
             <a:r>
               <a:rPr lang="en-US" sz="1000" dirty="0">
                 <a:solidFill>
-                  <a:srgbClr val="999999"/>
+                  <a:srgbClr val="CDD6F4"/>
                 </a:solidFill>
               </a:rPr>
               <a:t>Footer - Copyright © 2026 Nexus</a:t>

</xml_diff>